<commit_message>
Sections export as PowerPoint's, the slides before the first in its "Default Section", which the import reads back as no section, and editide without edit_sections reports them as a gap; the fixture decks carry them, so --diff compares sections too
Co-Authored-By: Claude Opus 5.5 <noreply@anthropic.com>
</commit_message>
<xml_diff>
--- a/src/Pintura.Tests/fixtures/pptx/balance-sheet.pptx
+++ b/src/Pintura.Tests/fixtures/pptx/balance-sheet.pptx
@@ -5,12 +5,12 @@
     <p:sldMasterId id="2147483648" r:id="rId1"/>
   </p:sldMasterIdLst>
   <p:sldIdLst>
-    <p:sldId id="257" r:id="R5b6087019bc047c4"/>
-    <p:sldId id="258" r:id="Rf248ca5435274d97"/>
-    <p:sldId id="259" r:id="Rce7d6aa5191c4a01"/>
-    <p:sldId id="260" r:id="Rcf5ffe7a4c8047e4"/>
-    <p:sldId id="261" r:id="R183769ed0a034665"/>
-    <p:sldId id="262" r:id="R2ac068e48e67404d"/>
+    <p:sldId id="257" r:id="R38e19617fbcf4936"/>
+    <p:sldId id="258" r:id="R67da2d37dbd54b1b"/>
+    <p:sldId id="259" r:id="R4ba280e16a6d4374"/>
+    <p:sldId id="260" r:id="Rc27f2a40102545ce"/>
+    <p:sldId id="261" r:id="Rf3e60943ef6e44e7"/>
+    <p:sldId id="262" r:id="R72631d05ef1a40a5"/>
   </p:sldIdLst>
   <p:sldSz cx="12192000" cy="6858000"/>
   <p:notesSz cx="6858000" cy="9144000"/>
@@ -109,145 +109,34 @@
       </a:defRPr>
     </a:lvl9pPr>
   </p:defaultTextStyle>
+  <p:extLst>
+    <p:ext uri="{521415D9-36F7-43E2-AB2F-B90AF26B5E84}">
+      <p14:sectionLst xmlns:p14="http://schemas.microsoft.com/office/powerpoint/2010/main">
+        <p14:section name="Default Section" id="{872F7692-F404-4B14-AFAD-BE1B76A565E0}">
+          <p14:sldIdLst>
+            <p14:sldId id="257"/>
+          </p14:sldIdLst>
+        </p14:section>
+        <p14:section name="Balance sheet" id="{D03F17A3-A40A-4CE1-9BD8-85781C4755E1}">
+          <p14:sldIdLst>
+            <p14:sldId id="258"/>
+            <p14:sldId id="259"/>
+          </p14:sldIdLst>
+        </p14:section>
+        <p14:section name="Cash flow" id="{C85E1DEB-1F43-40AB-8F2F-A03B18DCFA4D}">
+          <p14:sldIdLst>
+            <p14:sldId id="260"/>
+            <p14:sldId id="261"/>
+            <p14:sldId id="262"/>
+          </p14:sldIdLst>
+        </p14:section>
+      </p14:sectionLst>
+    </p:ext>
+  </p:extLst>
 </p:presentation>
 </file>
 
 <file path=ppt/slideLayouts/slideLayout2.xml><?xml version="1.0" encoding="utf-8"?>
-<p:sldLayout xmlns:a="http://schemas.openxmlformats.org/drawingml/2006/main" xmlns:p="http://schemas.openxmlformats.org/presentationml/2006/main" preserve="1">
-  <p:cSld name="Blank">
-    <p:spTree>
-      <p:nvGrpSpPr>
-        <p:cNvPr id="1" name=""/>
-        <p:cNvGrpSpPr/>
-        <p:nvPr/>
-      </p:nvGrpSpPr>
-      <p:grpSpPr>
-        <a:xfrm xmlns:a="http://schemas.openxmlformats.org/drawingml/2006/main"/>
-      </p:grpSpPr>
-      <p:sp>
-        <p:nvSpPr>
-          <p:cNvPr id="2" name="TextBox 2"/>
-          <p:cNvSpPr>
-            <a:spLocks/>
-          </p:cNvSpPr>
-          <p:nvPr>
-            <p:ph type="sldNum" idx="12"/>
-          </p:nvPr>
-        </p:nvSpPr>
-        <p:spPr>
-          <a:xfrm>
-            <a:off x="10922000" y="6451600"/>
-            <a:ext cx="762000" cy="279400"/>
-          </a:xfrm>
-          <a:prstGeom prst="rect">
-            <a:avLst/>
-          </a:prstGeom>
-        </p:spPr>
-        <p:txBody>
-          <a:bodyPr wrap="square" lIns="91440" tIns="45720" rIns="91440" bIns="45720" anchor="t">
-            <a:noAutofit/>
-          </a:bodyPr>
-          <a:lstStyle>
-            <a:lvl1pPr algn="r">
-              <a:lnSpc>
-                <a:spcPct val="100000"/>
-              </a:lnSpc>
-              <a:spcBef>
-                <a:spcPts val="0"/>
-              </a:spcBef>
-              <a:spcAft>
-                <a:spcPts val="0"/>
-              </a:spcAft>
-              <a:buNone/>
-              <a:defRPr sz="1100" b="0" i="0" u="none">
-                <a:solidFill>
-                  <a:schemeClr val="dk1">
-                    <a:lumMod val="50000"/>
-                    <a:lumOff val="50000"/>
-                  </a:schemeClr>
-                </a:solidFill>
-                <a:latin typeface="+mn-lt"/>
-              </a:defRPr>
-            </a:lvl1pPr>
-          </a:lstStyle>
-          <a:p>
-            <a:fld id="{6D36A8F4-F374-4745-A0C8-56414D95506F}" type="slidenum">
-              <a:rPr lang="en-US"/>
-              <a:t>‹#›</a:t>
-            </a:fld>
-            <a:endParaRPr lang="en-US"/>
-          </a:p>
-        </p:txBody>
-      </p:sp>
-      <p:sp>
-        <p:nvSpPr>
-          <p:cNvPr id="3" name="TextBox 3"/>
-          <p:cNvSpPr>
-            <a:spLocks/>
-          </p:cNvSpPr>
-          <p:nvPr/>
-        </p:nvSpPr>
-        <p:spPr>
-          <a:xfrm>
-            <a:off x="508000" y="6451600"/>
-            <a:ext cx="7620000" cy="279400"/>
-          </a:xfrm>
-          <a:prstGeom prst="rect">
-            <a:avLst/>
-          </a:prstGeom>
-        </p:spPr>
-        <p:txBody>
-          <a:bodyPr wrap="square" lIns="91440" tIns="45720" rIns="91440" bIns="45720" anchor="t">
-            <a:noAutofit/>
-          </a:bodyPr>
-          <a:lstStyle/>
-          <a:p>
-            <a:pPr marL="0" indent="0" algn="l">
-              <a:lnSpc>
-                <a:spcPct val="100000"/>
-              </a:lnSpc>
-              <a:spcBef>
-                <a:spcPts val="0"/>
-              </a:spcBef>
-              <a:spcAft>
-                <a:spcPts val="0"/>
-              </a:spcAft>
-              <a:buNone/>
-            </a:pPr>
-            <a:r>
-              <a:rPr sz="1100" b="0" i="0" u="none">
-                <a:solidFill>
-                  <a:schemeClr val="dk1">
-                    <a:lumMod val="50000"/>
-                    <a:lumOff val="50000"/>
-                  </a:schemeClr>
-                </a:solidFill>
-                <a:latin typeface="+mn-lt"/>
-              </a:rPr>
-              <a:t>Acme board update. USD millions unless noted.</a:t>
-            </a:r>
-            <a:endParaRPr sz="1100" b="0" i="0" u="none">
-              <a:solidFill>
-                <a:schemeClr val="dk1">
-                  <a:lumMod val="50000"/>
-                  <a:lumOff val="50000"/>
-                </a:schemeClr>
-              </a:solidFill>
-              <a:latin typeface="+mn-lt"/>
-            </a:endParaRPr>
-          </a:p>
-        </p:txBody>
-      </p:sp>
-    </p:spTree>
-  </p:cSld>
-  <p:clrMapOvr>
-    <a:masterClrMapping xmlns:a="http://schemas.openxmlformats.org/drawingml/2006/main"/>
-  </p:clrMapOvr>
-  <p:hf hdr="0"/>
-</p:sldLayout>
-</file>
-
-<file path=ppt/slideLayouts/slideLayout3.xml><?xml version="1.0" encoding="utf-8"?>
 <p:sldLayout xmlns:a="http://schemas.openxmlformats.org/drawingml/2006/main" xmlns:p="http://schemas.openxmlformats.org/presentationml/2006/main" preserve="1">
   <p:cSld name="Content">
     <p:spTree>
@@ -343,7 +232,7 @@
             </a:lvl1pPr>
           </a:lstStyle>
           <a:p>
-            <a:fld id="{01962F80-41F8-4FFD-B1CB-4CA59F167652}" type="slidenum">
+            <a:fld id="{F0FCB394-2755-4E9F-87E1-3B710EE2982A}" type="slidenum">
               <a:rPr lang="en-US"/>
               <a:t>‹#›</a:t>
             </a:fld>
@@ -419,7 +308,7 @@
 </p:sldLayout>
 </file>
 
-<file path=ppt/slideLayouts/slideLayout4.xml><?xml version="1.0" encoding="utf-8"?>
+<file path=ppt/slideLayouts/slideLayout3.xml><?xml version="1.0" encoding="utf-8"?>
 <p:sldLayout xmlns:a="http://schemas.openxmlformats.org/drawingml/2006/main" xmlns:p="http://schemas.openxmlformats.org/presentationml/2006/main" preserve="1">
   <p:cSld name="Section">
     <p:spTree>
@@ -559,7 +448,7 @@
             </a:lvl1pPr>
           </a:lstStyle>
           <a:p>
-            <a:fld id="{6DF15392-A4E9-4E6E-8BEE-F8BF675D2B10}" type="slidenum">
+            <a:fld id="{A96C89CA-71FE-4323-9263-EC9AFA48F836}" type="slidenum">
               <a:rPr lang="en-US"/>
               <a:t>‹#›</a:t>
             </a:fld>
@@ -635,7 +524,7 @@
 </p:sldLayout>
 </file>
 
-<file path=ppt/slideLayouts/slideLayout5.xml><?xml version="1.0" encoding="utf-8"?>
+<file path=ppt/slideLayouts/slideLayout4.xml><?xml version="1.0" encoding="utf-8"?>
 <p:sldLayout xmlns:a="http://schemas.openxmlformats.org/drawingml/2006/main" xmlns:p="http://schemas.openxmlformats.org/presentationml/2006/main" preserve="1">
   <p:cSld name="Title">
     <p:spTree>
@@ -738,7 +627,7 @@
 
 <file path=ppt/slideMasters/slideMaster1.xml><?xml version="1.0" encoding="utf-8"?>
 <p:sldMaster xmlns:a16="http://schemas.microsoft.com/office/drawing/2014/main" xmlns:p14="http://schemas.microsoft.com/office/powerpoint/2010/main" xmlns:a="http://schemas.openxmlformats.org/drawingml/2006/main" xmlns:r="http://schemas.openxmlformats.org/officeDocument/2006/relationships" xmlns:p="http://schemas.openxmlformats.org/presentationml/2006/main">
-  <p:cSld>
+  <p:cSld name="Default">
     <p:bg>
       <p:bgPr>
         <a:solidFill>
@@ -1012,10 +901,9 @@
   </p:cSld>
   <p:clrMap bg1="lt1" tx1="dk1" bg2="lt2" tx2="dk2" accent1="accent1" accent2="accent2" accent3="accent3" accent4="accent4" accent5="accent5" accent6="accent6" hlink="hlink" folHlink="folHlink"/>
   <p:sldLayoutIdLst>
-    <p:sldLayoutId id="2147483650" r:id="R6fc6f4203fe04ced"/>
-    <p:sldLayoutId id="2147483651" r:id="R2a82274228f84f3c"/>
-    <p:sldLayoutId id="2147483652" r:id="R12965888627d4d82"/>
-    <p:sldLayoutId id="2147483653" r:id="Rf9c919e89a1545e2"/>
+    <p:sldLayoutId id="2147483650" r:id="Rb077e916b83c4447"/>
+    <p:sldLayoutId id="2147483651" r:id="Rcaa04995bcc74a9f"/>
+    <p:sldLayoutId id="2147483652" r:id="Rc45b1ff5581e46f0"/>
   </p:sldLayoutIdLst>
   <p:txStyles>
     <p:titleStyle>
@@ -1711,7 +1599,7 @@
     <c:plotVisOnly val="1"/>
     <c:dispBlanksAs val="gap"/>
   </c:chart>
-  <c:externalData xmlns:r="http://schemas.openxmlformats.org/officeDocument/2006/relationships" r:id="R0bf7690cc8454cfc">
+  <c:externalData xmlns:r="http://schemas.openxmlformats.org/officeDocument/2006/relationships" r:id="Rec02bc9d7ccd45e2">
     <c:autoUpdate val="0"/>
   </c:externalData>
 </c:chartSpace>
@@ -1919,7 +1807,7 @@
             </a:lvl1pPr>
           </a:lstStyle>
           <a:p xmlns:a="http://schemas.openxmlformats.org/drawingml/2006/main">
-            <a:fld id="{6DF15392-A4E9-4E6E-8BEE-F8BF675D2B10}" type="slidenum">
+            <a:fld id="{A96C89CA-71FE-4323-9263-EC9AFA48F836}" type="slidenum">
               <a:rPr lang="en-US"/>
               <a:t>‹#›</a:t>
             </a:fld>
@@ -4241,7 +4129,7 @@
             </a:lvl1pPr>
           </a:lstStyle>
           <a:p xmlns:a="http://schemas.openxmlformats.org/drawingml/2006/main">
-            <a:fld id="{01962F80-41F8-4FFD-B1CB-4CA59F167652}" type="slidenum">
+            <a:fld id="{F0FCB394-2755-4E9F-87E1-3B710EE2982A}" type="slidenum">
               <a:rPr lang="en-US"/>
               <a:t>‹#›</a:t>
             </a:fld>
@@ -4370,7 +4258,7 @@
             </a:lvl1pPr>
           </a:lstStyle>
           <a:p xmlns:a="http://schemas.openxmlformats.org/drawingml/2006/main">
-            <a:fld id="{6DF15392-A4E9-4E6E-8BEE-F8BF675D2B10}" type="slidenum">
+            <a:fld id="{A96C89CA-71FE-4323-9263-EC9AFA48F836}" type="slidenum">
               <a:rPr lang="en-US"/>
               <a:t>‹#›</a:t>
             </a:fld>
@@ -4438,7 +4326,7 @@
         </p:xfrm>
         <a:graphic>
           <a:graphicData uri="http://schemas.openxmlformats.org/drawingml/2006/chart">
-            <c:chart xmlns:r="http://schemas.openxmlformats.org/officeDocument/2006/relationships" xmlns:c="http://schemas.openxmlformats.org/drawingml/2006/chart" r:id="Rfb7e5b456b9445e1"/>
+            <c:chart xmlns:r="http://schemas.openxmlformats.org/officeDocument/2006/relationships" xmlns:c="http://schemas.openxmlformats.org/drawingml/2006/chart" r:id="R890218ee71614bfa"/>
           </a:graphicData>
         </a:graphic>
       </p:graphicFrame>
@@ -4782,7 +4670,7 @@
             </a:lvl1pPr>
           </a:lstStyle>
           <a:p xmlns:a="http://schemas.openxmlformats.org/drawingml/2006/main">
-            <a:fld id="{01962F80-41F8-4FFD-B1CB-4CA59F167652}" type="slidenum">
+            <a:fld id="{F0FCB394-2755-4E9F-87E1-3B710EE2982A}" type="slidenum">
               <a:rPr lang="en-US"/>
               <a:t>‹#›</a:t>
             </a:fld>
@@ -5592,7 +5480,7 @@
             </a:lvl1pPr>
           </a:lstStyle>
           <a:p xmlns:a="http://schemas.openxmlformats.org/drawingml/2006/main">
-            <a:fld id="{01962F80-41F8-4FFD-B1CB-4CA59F167652}" type="slidenum">
+            <a:fld id="{F0FCB394-2755-4E9F-87E1-3B710EE2982A}" type="slidenum">
               <a:rPr lang="en-US"/>
               <a:t>‹#›</a:t>
             </a:fld>
@@ -5606,7 +5494,7 @@
 </file>
 
 <file path=ppt/theme/theme1.xml><?xml version="1.0" encoding="utf-8"?>
-<a:theme xmlns:thm15="http://schemas.microsoft.com/office/thememl/2012/main" xmlns:a="http://schemas.openxmlformats.org/drawingml/2006/main" name="Office Theme">
+<a:theme xmlns:thm15="http://schemas.microsoft.com/office/thememl/2012/main" xmlns:a="http://schemas.openxmlformats.org/drawingml/2006/main" name="Default">
   <a:themeElements>
     <a:clrScheme name="Office">
       <a:dk1>

</xml_diff>

<commit_message>
The balance sheet's stored deck is exported again, so it carries the cash-flow chart's pinned value axis and imports as the fixture
Co-Authored-By: Claude Opus 5.5 <noreply@anthropic.com>
</commit_message>
<xml_diff>
--- a/src/Pintura.Tests/fixtures/pptx/balance-sheet.pptx
+++ b/src/Pintura.Tests/fixtures/pptx/balance-sheet.pptx
@@ -5,12 +5,12 @@
     <p:sldMasterId id="2147483648" r:id="rId1"/>
   </p:sldMasterIdLst>
   <p:sldIdLst>
-    <p:sldId id="257" r:id="R38e19617fbcf4936"/>
-    <p:sldId id="258" r:id="R67da2d37dbd54b1b"/>
-    <p:sldId id="259" r:id="R4ba280e16a6d4374"/>
-    <p:sldId id="260" r:id="Rc27f2a40102545ce"/>
-    <p:sldId id="261" r:id="Rf3e60943ef6e44e7"/>
-    <p:sldId id="262" r:id="R72631d05ef1a40a5"/>
+    <p:sldId id="257" r:id="R9325e42071894e00"/>
+    <p:sldId id="258" r:id="R759280891ced4572"/>
+    <p:sldId id="259" r:id="R38368f9b28614984"/>
+    <p:sldId id="260" r:id="Rb6e84d0f11ec4fb2"/>
+    <p:sldId id="261" r:id="R04731a6c57d34af7"/>
+    <p:sldId id="262" r:id="Rcec0657e8d704e8d"/>
   </p:sldIdLst>
   <p:sldSz cx="12192000" cy="6858000"/>
   <p:notesSz cx="6858000" cy="9144000"/>
@@ -112,18 +112,18 @@
   <p:extLst>
     <p:ext uri="{521415D9-36F7-43E2-AB2F-B90AF26B5E84}">
       <p14:sectionLst xmlns:p14="http://schemas.microsoft.com/office/powerpoint/2010/main">
-        <p14:section name="Default Section" id="{872F7692-F404-4B14-AFAD-BE1B76A565E0}">
+        <p14:section name="Default Section" id="{858864BC-B59B-40E6-8A71-ACAB8D2C9564}">
           <p14:sldIdLst>
             <p14:sldId id="257"/>
           </p14:sldIdLst>
         </p14:section>
-        <p14:section name="Balance sheet" id="{D03F17A3-A40A-4CE1-9BD8-85781C4755E1}">
+        <p14:section name="Balance sheet" id="{D7A8B7A2-640C-4176-835C-10EE348B993A}">
           <p14:sldIdLst>
             <p14:sldId id="258"/>
             <p14:sldId id="259"/>
           </p14:sldIdLst>
         </p14:section>
-        <p14:section name="Cash flow" id="{C85E1DEB-1F43-40AB-8F2F-A03B18DCFA4D}">
+        <p14:section name="Cash flow" id="{65E19E8A-5253-49D9-9DFD-89804687AB54}">
           <p14:sldIdLst>
             <p14:sldId id="260"/>
             <p14:sldId id="261"/>
@@ -232,7 +232,7 @@
             </a:lvl1pPr>
           </a:lstStyle>
           <a:p>
-            <a:fld id="{F0FCB394-2755-4E9F-87E1-3B710EE2982A}" type="slidenum">
+            <a:fld id="{946F43AB-3C5D-4C1C-9B2D-20E8F6DF88E3}" type="slidenum">
               <a:rPr lang="en-US"/>
               <a:t>‹#›</a:t>
             </a:fld>
@@ -448,7 +448,7 @@
             </a:lvl1pPr>
           </a:lstStyle>
           <a:p>
-            <a:fld id="{A96C89CA-71FE-4323-9263-EC9AFA48F836}" type="slidenum">
+            <a:fld id="{33E8EA01-BBF9-4B70-B395-D5EC6A8E80F7}" type="slidenum">
               <a:rPr lang="en-US"/>
               <a:t>‹#›</a:t>
             </a:fld>
@@ -901,9 +901,9 @@
   </p:cSld>
   <p:clrMap bg1="lt1" tx1="dk1" bg2="lt2" tx2="dk2" accent1="accent1" accent2="accent2" accent3="accent3" accent4="accent4" accent5="accent5" accent6="accent6" hlink="hlink" folHlink="folHlink"/>
   <p:sldLayoutIdLst>
-    <p:sldLayoutId id="2147483650" r:id="Rb077e916b83c4447"/>
-    <p:sldLayoutId id="2147483651" r:id="Rcaa04995bcc74a9f"/>
-    <p:sldLayoutId id="2147483652" r:id="Rc45b1ff5581e46f0"/>
+    <p:sldLayoutId id="2147483650" r:id="R10c370d116f340d8"/>
+    <p:sldLayoutId id="2147483651" r:id="Rfe544a7357cb42da"/>
+    <p:sldLayoutId id="2147483652" r:id="R42aaeef913e149b5"/>
   </p:sldLayoutIdLst>
   <p:txStyles>
     <p:titleStyle>
@@ -1533,8 +1533,8 @@
         <c:axId val="222222222"/>
         <c:scaling>
           <c:orientation val="minMax"/>
-          <c:max val="30000"/>
-          <c:min val="-25000"/>
+          <c:max val="40000"/>
+          <c:min val="-30000"/>
         </c:scaling>
         <c:delete val="0"/>
         <c:axPos val="l"/>
@@ -1576,7 +1576,7 @@
         <c:crossAx val="111111111"/>
         <c:crosses val="autoZero"/>
         <c:crossBetween val="between"/>
-        <c:majorUnit val="5000"/>
+        <c:majorUnit val="10000"/>
       </c:valAx>
     </c:plotArea>
     <c:legend>
@@ -1599,7 +1599,7 @@
     <c:plotVisOnly val="1"/>
     <c:dispBlanksAs val="gap"/>
   </c:chart>
-  <c:externalData xmlns:r="http://schemas.openxmlformats.org/officeDocument/2006/relationships" r:id="Rec02bc9d7ccd45e2">
+  <c:externalData xmlns:r="http://schemas.openxmlformats.org/officeDocument/2006/relationships" r:id="Rf17382fc88164717">
     <c:autoUpdate val="0"/>
   </c:externalData>
 </c:chartSpace>
@@ -1807,7 +1807,7 @@
             </a:lvl1pPr>
           </a:lstStyle>
           <a:p xmlns:a="http://schemas.openxmlformats.org/drawingml/2006/main">
-            <a:fld id="{A96C89CA-71FE-4323-9263-EC9AFA48F836}" type="slidenum">
+            <a:fld id="{33E8EA01-BBF9-4B70-B395-D5EC6A8E80F7}" type="slidenum">
               <a:rPr lang="en-US"/>
               <a:t>‹#›</a:t>
             </a:fld>
@@ -4129,7 +4129,7 @@
             </a:lvl1pPr>
           </a:lstStyle>
           <a:p xmlns:a="http://schemas.openxmlformats.org/drawingml/2006/main">
-            <a:fld id="{F0FCB394-2755-4E9F-87E1-3B710EE2982A}" type="slidenum">
+            <a:fld id="{946F43AB-3C5D-4C1C-9B2D-20E8F6DF88E3}" type="slidenum">
               <a:rPr lang="en-US"/>
               <a:t>‹#›</a:t>
             </a:fld>
@@ -4258,7 +4258,7 @@
             </a:lvl1pPr>
           </a:lstStyle>
           <a:p xmlns:a="http://schemas.openxmlformats.org/drawingml/2006/main">
-            <a:fld id="{A96C89CA-71FE-4323-9263-EC9AFA48F836}" type="slidenum">
+            <a:fld id="{33E8EA01-BBF9-4B70-B395-D5EC6A8E80F7}" type="slidenum">
               <a:rPr lang="en-US"/>
               <a:t>‹#›</a:t>
             </a:fld>
@@ -4326,7 +4326,7 @@
         </p:xfrm>
         <a:graphic>
           <a:graphicData uri="http://schemas.openxmlformats.org/drawingml/2006/chart">
-            <c:chart xmlns:r="http://schemas.openxmlformats.org/officeDocument/2006/relationships" xmlns:c="http://schemas.openxmlformats.org/drawingml/2006/chart" r:id="R890218ee71614bfa"/>
+            <c:chart xmlns:r="http://schemas.openxmlformats.org/officeDocument/2006/relationships" xmlns:c="http://schemas.openxmlformats.org/drawingml/2006/chart" r:id="R2d92146398fe436e"/>
           </a:graphicData>
         </a:graphic>
       </p:graphicFrame>
@@ -4670,7 +4670,7 @@
             </a:lvl1pPr>
           </a:lstStyle>
           <a:p xmlns:a="http://schemas.openxmlformats.org/drawingml/2006/main">
-            <a:fld id="{F0FCB394-2755-4E9F-87E1-3B710EE2982A}" type="slidenum">
+            <a:fld id="{946F43AB-3C5D-4C1C-9B2D-20E8F6DF88E3}" type="slidenum">
               <a:rPr lang="en-US"/>
               <a:t>‹#›</a:t>
             </a:fld>
@@ -5480,7 +5480,7 @@
             </a:lvl1pPr>
           </a:lstStyle>
           <a:p xmlns:a="http://schemas.openxmlformats.org/drawingml/2006/main">
-            <a:fld id="{F0FCB394-2755-4E9F-87E1-3B710EE2982A}" type="slidenum">
+            <a:fld id="{946F43AB-3C5D-4C1C-9B2D-20E8F6DF88E3}" type="slidenum">
               <a:rPr lang="en-US"/>
               <a:t>‹#›</a:t>
             </a:fld>

</xml_diff>